<commit_message>
try to complete video
</commit_message>
<xml_diff>
--- a/icra_video/cast_video_slides.pptx
+++ b/icra_video/cast_video_slides.pptx
@@ -511,7 +511,7 @@
           <a:lstStyle/>
           <a:p>
             <a:r>
-              <a:t>00:00–00:10 | 10 seconds</a:t>
+              <a:t>00:00–00:06 | 6 seconds</a:t>
             </a:r>
           </a:p>
           <a:p/>
@@ -522,7 +522,28 @@
           </a:p>
           <a:p>
             <a:r>
-              <a:t>A robot can position an object correctly, yet fail at release. CAST improves the skill while preserving behavior that already works.</a:t>
+              <a:t>We introduce CAST, which improves robot skills while keeping the original policy as a reference.</a:t>
+            </a:r>
+          </a:p>
+          <a:p/>
+          <a:p>
+            <a:r>
+              <a:t>TIMED DELIVERY CUES (DIRECTIONS ARE NOT SPOKEN)</a:t>
+            </a:r>
+          </a:p>
+          <a:p>
+            <a:r>
+              <a:t>00:00–00:06</a:t>
+            </a:r>
+          </a:p>
+          <a:p>
+            <a:r>
+              <a:t>ON SCREEN: Title and OpenArm scene; introduce the problem.</a:t>
+            </a:r>
+          </a:p>
+          <a:p>
+            <a:r>
+              <a:t>SAY: We introduce CAST, which improves robot skills while keeping the original policy as a reference.</a:t>
             </a:r>
           </a:p>
           <a:p/>
@@ -614,7 +635,7 @@
           <a:lstStyle/>
           <a:p>
             <a:r>
-              <a:t>02:52–03:00 | 8 seconds</a:t>
+              <a:t>02:28–02:36 | 8 seconds</a:t>
             </a:r>
           </a:p>
           <a:p/>
@@ -625,7 +646,44 @@
           </a:p>
           <a:p>
             <a:r>
-              <a:t>CAST combines critic guidance, soft restoration, and bounded target steps: improve the skill while keeping a persistent reference.</a:t>
+              <a:t>In short, we guide improvement, limit each target step, and keep the original skill as a reference.</a:t>
+            </a:r>
+          </a:p>
+          <a:p/>
+          <a:p>
+            <a:r>
+              <a:t>TIMED DELIVERY CUES (DIRECTIONS ARE NOT SPOKEN)</a:t>
+            </a:r>
+          </a:p>
+          <a:p>
+            <a:r>
+              <a:t>02:28–02:32</a:t>
+            </a:r>
+          </a:p>
+          <a:p>
+            <a:r>
+              <a:t>ON SCREEN: Point through the three cards: critic guidance, soft restoration, bounded target steps.</a:t>
+            </a:r>
+          </a:p>
+          <a:p>
+            <a:r>
+              <a:t>SAY: In short, we guide improvement, limit each target step,</a:t>
+            </a:r>
+          </a:p>
+          <a:p/>
+          <a:p>
+            <a:r>
+              <a:t>02:32–02:36</a:t>
+            </a:r>
+          </a:p>
+          <a:p>
+            <a:r>
+              <a:t>ON SCREEN: Hold the closing title and project address.</a:t>
+            </a:r>
+          </a:p>
+          <a:p>
+            <a:r>
+              <a:t>SAY: and keep the original skill as a reference.</a:t>
             </a:r>
           </a:p>
           <a:p/>
@@ -717,7 +775,7 @@
           <a:lstStyle/>
           <a:p>
             <a:r>
-              <a:t>00:10–00:30 | 20 seconds</a:t>
+              <a:t>00:06–00:18 | 12 seconds</a:t>
             </a:r>
           </a:p>
           <a:p/>
@@ -728,7 +786,60 @@
           </a:p>
           <a:p>
             <a:r>
-              <a:t>A critic predicts which actions are valuable. Here, its predictions favor actions far from the useful region. Watch the action distributions shift during optimization. Clipping keeps each correction small, but repeated corrections still drift. CAST restores toward the frozen base while allowing a useful adjustment. This is an illustrative toy example.</a:t>
+              <a:t>This matters because the critic can misjudge which actions are better. As orange shows, even small updates can drift away. CAST pulls back, as green shows.</a:t>
+            </a:r>
+          </a:p>
+          <a:p/>
+          <a:p>
+            <a:r>
+              <a:t>TIMED DELIVERY CUES (DIRECTIONS ARE NOT SPOKEN)</a:t>
+            </a:r>
+          </a:p>
+          <a:p>
+            <a:r>
+              <a:t>00:06–00:11</a:t>
+            </a:r>
+          </a:p>
+          <a:p>
+            <a:r>
+              <a:t>ON SCREEN: A01: the toy critic curve predicts which actions are valuable.</a:t>
+            </a:r>
+          </a:p>
+          <a:p>
+            <a:r>
+              <a:t>SAY: This matters because the critic can misjudge which actions are better.</a:t>
+            </a:r>
+          </a:p>
+          <a:p/>
+          <a:p>
+            <a:r>
+              <a:t>00:11–00:15</a:t>
+            </a:r>
+          </a:p>
+          <a:p>
+            <a:r>
+              <a:t>ON SCREEN: Orange: repeated clipped updates drift away from the blue base.</a:t>
+            </a:r>
+          </a:p>
+          <a:p>
+            <a:r>
+              <a:t>SAY: As orange shows, even small updates can drift away.</a:t>
+            </a:r>
+          </a:p>
+          <a:p/>
+          <a:p>
+            <a:r>
+              <a:t>00:15–00:18</a:t>
+            </a:r>
+          </a:p>
+          <a:p>
+            <a:r>
+              <a:t>ON SCREEN: Green: restoration keeps the updated policy near the base.</a:t>
+            </a:r>
+          </a:p>
+          <a:p>
+            <a:r>
+              <a:t>SAY: CAST pulls back, as green shows.</a:t>
             </a:r>
           </a:p>
           <a:p/>
@@ -825,7 +936,7 @@
           <a:lstStyle/>
           <a:p>
             <a:r>
-              <a:t>00:30–00:45 | 15 seconds</a:t>
+              <a:t>00:18–00:26 | 8 seconds</a:t>
             </a:r>
           </a:p>
           <a:p/>
@@ -836,7 +947,44 @@
           </a:p>
           <a:p>
             <a:r>
-              <a:t>We freeze the generative policy and learn an additive residual. The same observation and noise pair each current action with its base action, giving corrections a consistent reference without policy likelihoods.</a:t>
+              <a:t>So we keep the original policy fixed and learn a correction. Each action keeps its own reference.</a:t>
+            </a:r>
+          </a:p>
+          <a:p/>
+          <a:p>
+            <a:r>
+              <a:t>TIMED DELIVERY CUES (DIRECTIONS ARE NOT SPOKEN)</a:t>
+            </a:r>
+          </a:p>
+          <a:p>
+            <a:r>
+              <a:t>00:18–00:23</a:t>
+            </a:r>
+          </a:p>
+          <a:p>
+            <a:r>
+              <a:t>ON SCREEN: A02: frozen base plus learned residual; point to the sum.</a:t>
+            </a:r>
+          </a:p>
+          <a:p>
+            <a:r>
+              <a:t>SAY: So we keep the original policy fixed and learn a correction.</a:t>
+            </a:r>
+          </a:p>
+          <a:p/>
+          <a:p>
+            <a:r>
+              <a:t>00:23–00:26</a:t>
+            </a:r>
+          </a:p>
+          <a:p>
+            <a:r>
+              <a:t>ON SCREEN: The paired samples share the same observation and noise.</a:t>
+            </a:r>
+          </a:p>
+          <a:p>
+            <a:r>
+              <a:t>SAY: Each action keeps its own reference.</a:t>
             </a:r>
           </a:p>
           <a:p/>
@@ -933,7 +1081,7 @@
           <a:lstStyle/>
           <a:p>
             <a:r>
-              <a:t>00:45–01:10 | 25 seconds</a:t>
+              <a:t>00:26–00:56 | 30 seconds</a:t>
             </a:r>
           </a:p>
           <a:p/>
@@ -944,18 +1092,151 @@
           </a:p>
           <a:p>
             <a:r>
-              <a:t>First, the critic proposes an improvement. We normalize and cap its gradient, then scale the proposal. A weak pull always points toward the paired base action. Beyond a soft reference radius, an additional radial pull becomes active. We add these fields and cap the final step from the current action. The resulting target teaches the residual policy.</a:t>
+              <a:t>Here’s one learning step. We first sample paired actions. Next, the critic proposes an improvement. We normalize, cap, and scale its gradient. We also pull toward the base, with a stronger pull beyond the reference radius. We combine these arrows and cap the target step around the current action. We then fit the correction to these fixed targets, and repeat the process.</a:t>
             </a:r>
           </a:p>
           <a:p/>
           <a:p>
             <a:r>
+              <a:t>TIMED DELIVERY CUES (DIRECTIONS ARE NOT SPOKEN)</a:t>
+            </a:r>
+          </a:p>
+          <a:p>
+            <a:r>
+              <a:t>00:26–00:28</a:t>
+            </a:r>
+          </a:p>
+          <a:p>
+            <a:r>
+              <a:t>ON SCREEN: A03: clockwise overview of Figure 2.</a:t>
+            </a:r>
+          </a:p>
+          <a:p>
+            <a:r>
+              <a:t>SAY: Here’s one learning step.</a:t>
+            </a:r>
+          </a:p>
+          <a:p/>
+          <a:p>
+            <a:r>
+              <a:t>00:28–00:31</a:t>
+            </a:r>
+          </a:p>
+          <a:p>
+            <a:r>
+              <a:t>ON SCREEN: Sample panel: base/current pairs and residual arrows.</a:t>
+            </a:r>
+          </a:p>
+          <a:p>
+            <a:r>
+              <a:t>SAY: We first sample paired actions.</a:t>
+            </a:r>
+          </a:p>
+          <a:p/>
+          <a:p>
+            <a:r>
+              <a:t>00:31–00:37</a:t>
+            </a:r>
+          </a:p>
+          <a:p>
+            <a:r>
+              <a:t>ON SCREEN: Critic panel: normalized gradient appears, then contracts to its cap. Scaling follows the cap.</a:t>
+            </a:r>
+          </a:p>
+          <a:p>
+            <a:r>
+              <a:t>SAY: Next, the critic proposes an improvement. We normalize, cap, and scale its gradient.</a:t>
+            </a:r>
+          </a:p>
+          <a:p/>
+          <a:p>
+            <a:r>
+              <a:t>00:37–00:40</a:t>
+            </a:r>
+          </a:p>
+          <a:p>
+            <a:r>
+              <a:t>ON SCREEN: Restoration panel: weak pull toward the paired base action.</a:t>
+            </a:r>
+          </a:p>
+          <a:p>
+            <a:r>
+              <a:t>SAY: We also pull toward the base,</a:t>
+            </a:r>
+          </a:p>
+          <a:p/>
+          <a:p>
+            <a:r>
+              <a:t>00:40–00:44</a:t>
+            </a:r>
+          </a:p>
+          <a:p>
+            <a:r>
+              <a:t>ON SCREEN: Additional radial restoration appears beyond the reference radius.</a:t>
+            </a:r>
+          </a:p>
+          <a:p>
+            <a:r>
+              <a:t>SAY: with a stronger pull beyond the reference radius.</a:t>
+            </a:r>
+          </a:p>
+          <a:p/>
+          <a:p>
+            <a:r>
+              <a:t>00:44–00:50</a:t>
+            </a:r>
+          </a:p>
+          <a:p>
+            <a:r>
+              <a:t>ON SCREEN: Combine the vectors and clip around the CURRENT action. The circle bounds the target step.</a:t>
+            </a:r>
+          </a:p>
+          <a:p>
+            <a:r>
+              <a:t>SAY: We combine these arrows and cap the target step around the current action.</a:t>
+            </a:r>
+          </a:p>
+          <a:p/>
+          <a:p>
+            <a:r>
+              <a:t>00:50–00:54</a:t>
+            </a:r>
+          </a:p>
+          <a:p>
+            <a:r>
+              <a:t>ON SCREEN: Fit panel: regression to fixed residual targets; squared-error equation.</a:t>
+            </a:r>
+          </a:p>
+          <a:p>
+            <a:r>
+              <a:t>SAY: We then fit the correction to these fixed targets,</a:t>
+            </a:r>
+          </a:p>
+          <a:p/>
+          <a:p>
+            <a:r>
+              <a:t>00:54–00:56</a:t>
+            </a:r>
+          </a:p>
+          <a:p>
+            <a:r>
+              <a:t>ON SCREEN: Return to the complete clockwise figure; leave a short breath.</a:t>
+            </a:r>
+          </a:p>
+          <a:p>
+            <a:r>
+              <a:t>SAY: and repeat the process.</a:t>
+            </a:r>
+          </a:p>
+          <a:p/>
+          <a:p>
+            <a:r>
               <a:t>VISUAL CUES</a:t>
             </a:r>
           </a:p>
           <a:p>
             <a:r>
-              <a:t>A03: Animate the normalized critic proposal, paired weak/radial restoration, and combined displacement cap. Restoration is evaluated at the current action.</a:t>
+              <a:t>A03: Reuse the submitted figure samples and vectors. Reveal the matching equations and zoom into each clockwise stage. Show the raw critic request contracting to the critic cap, then restoration and total clipping around the current action.</a:t>
             </a:r>
           </a:p>
           <a:p/>
@@ -967,6 +1248,21 @@
           <a:p>
             <a:r>
               <a:t>_ICRA_2027__CAST/sections/04_method.tex</a:t>
+            </a:r>
+          </a:p>
+          <a:p>
+            <a:r>
+              <a:t>_ICRA_2027__CAST/sections/04_method_figure.tex</a:t>
+            </a:r>
+          </a:p>
+          <a:p>
+            <a:r>
+              <a:t>_ICRA_2027__CAST/figures/method_update.npz</a:t>
+            </a:r>
+          </a:p>
+          <a:p>
+            <a:r>
+              <a:t>_ICRA_2027__CAST/figures/method_update.json</a:t>
             </a:r>
           </a:p>
         </p:txBody>
@@ -1036,7 +1332,7 @@
           <a:lstStyle/>
           <a:p>
             <a:r>
-              <a:t>01:10–01:32 | 22 seconds</a:t>
+              <a:t>00:56–01:06 | 10 seconds</a:t>
             </a:r>
           </a:p>
           <a:p/>
@@ -1047,7 +1343,60 @@
           </a:p>
           <a:p>
             <a:r>
-              <a:t>The squares are fixed targets. The white actor learns to match them by regression; its fitting error decreases. Then we construct new targets and repeat. Restoration corresponds to a penalty on departure from the base. With clipping inactive, the first regression gradient follows regularized critic optimization. The reference stays soft, leaving room to improve.</a:t>
+              <a:t>The policy now learns to match the fixed green targets. We refresh them and repeat, while the soft pull leaves room to improve.</a:t>
+            </a:r>
+          </a:p>
+          <a:p/>
+          <a:p>
+            <a:r>
+              <a:t>TIMED DELIVERY CUES (DIRECTIONS ARE NOT SPOKEN)</a:t>
+            </a:r>
+          </a:p>
+          <a:p>
+            <a:r>
+              <a:t>00:56–01:01</a:t>
+            </a:r>
+          </a:p>
+          <a:p>
+            <a:r>
+              <a:t>ON SCREEN: A04: the actor moves toward the fixed green squares; fitting error falls.</a:t>
+            </a:r>
+          </a:p>
+          <a:p>
+            <a:r>
+              <a:t>SAY: The policy now learns to match the fixed green targets.</a:t>
+            </a:r>
+          </a:p>
+          <a:p/>
+          <a:p>
+            <a:r>
+              <a:t>01:01–01:03</a:t>
+            </a:r>
+          </a:p>
+          <a:p>
+            <a:r>
+              <a:t>ON SCREEN: The animation constructs fresh targets for another fitting round.</a:t>
+            </a:r>
+          </a:p>
+          <a:p>
+            <a:r>
+              <a:t>SAY: We refresh them and repeat,</a:t>
+            </a:r>
+          </a:p>
+          <a:p/>
+          <a:p>
+            <a:r>
+              <a:t>01:03–01:06</a:t>
+            </a:r>
+          </a:p>
+          <a:p>
+            <a:r>
+              <a:t>ON SCREEN: Right-hand curve: increasing restoration penalty, with a soft threshold.</a:t>
+            </a:r>
+          </a:p>
+          <a:p>
+            <a:r>
+              <a:t>SAY: while the soft pull leaves room to improve.</a:t>
             </a:r>
           </a:p>
           <a:p/>
@@ -1144,7 +1493,7 @@
           <a:lstStyle/>
           <a:p>
             <a:r>
-              <a:t>01:32–02:00 | 28 seconds</a:t>
+              <a:t>01:06–01:36 | 30 seconds</a:t>
             </a:r>
           </a:p>
           <a:p/>
@@ -1155,18 +1504,87 @@
           </a:p>
           <a:p>
             <a:r>
-              <a:t>On robomimic square, CAST reaches ninety percent success with thirty-eight percent fewer environment steps than DICE-RL, while final success is similar. In a separate five-task LIBERO study, both updates without restoration lose all task success, including clipping alone. Full CAST improves every task over its base, although radial restoration alone is better on two tasks.</a:t>
+              <a:t>We test this approach in LIBERO, robomimic, and DMC. These clips introduce the tasks. On robomimic square, CAST reaches ninety percent success using thirty-eight percent fewer environment steps than DICE-RL. On five LIBERO tasks, updates with no controls or clipping alone have zero success. CAST improves every task over the base, although radial restoration alone is better on two.</a:t>
             </a:r>
           </a:p>
           <a:p/>
           <a:p>
             <a:r>
+              <a:t>TIMED DELIVERY CUES (DIRECTIONS ARE NOT SPOKEN)</a:t>
+            </a:r>
+          </a:p>
+          <a:p>
+            <a:r>
+              <a:t>01:06–01:15</a:t>
+            </a:r>
+          </a:p>
+          <a:p>
+            <a:r>
+              <a:t>ON SCREEN: A05: LIBERO demonstration (0–3 s), robomimic demonstration (3–6 s), DMC scripted controller (6–9 s). These introduce the environments.</a:t>
+            </a:r>
+          </a:p>
+          <a:p>
+            <a:r>
+              <a:t>SAY: We test this approach in LIBERO, robomimic, and DMC. These clips introduce the tasks.</a:t>
+            </a:r>
+          </a:p>
+          <a:p/>
+          <a:p>
+            <a:r>
+              <a:t>01:15–01:24</a:t>
+            </a:r>
+          </a:p>
+          <a:p>
+            <a:r>
+              <a:t>ON SCREEN: Read the right-hand robomimic square efficiency chart; the left-hand LIBERO bars finish appearing.</a:t>
+            </a:r>
+          </a:p>
+          <a:p>
+            <a:r>
+              <a:t>SAY: On robomimic square, CAST reaches ninety percent success using thirty-eight percent fewer environment steps than DICE-RL.</a:t>
+            </a:r>
+          </a:p>
+          <a:p/>
+          <a:p>
+            <a:r>
+              <a:t>01:24–01:30</a:t>
+            </a:r>
+          </a:p>
+          <a:p>
+            <a:r>
+              <a:t>ON SCREEN: Left-hand LIBERO chart: no controls and clipping only both show zero. These are the five tested tasks.</a:t>
+            </a:r>
+          </a:p>
+          <a:p>
+            <a:r>
+              <a:t>SAY: On five LIBERO tasks, updates with no controls or clipping alone have zero success.</a:t>
+            </a:r>
+          </a:p>
+          <a:p/>
+          <a:p>
+            <a:r>
+              <a:t>01:30–01:36</a:t>
+            </a:r>
+          </a:p>
+          <a:p>
+            <a:r>
+              <a:t>ON SCREEN: CAST improves over the base on every task; the displayed bars aggregate five tasks. Radial-only beats CAST on two individual tasks.</a:t>
+            </a:r>
+          </a:p>
+          <a:p>
+            <a:r>
+              <a:t>SAY: CAST improves every task over the base, although radial restoration alone is better on two.</a:t>
+            </a:r>
+          </a:p>
+          <a:p/>
+          <a:p>
+            <a:r>
               <a:t>VISUAL CUES</a:t>
             </a:r>
           </a:p>
           <a:p>
             <a:r>
-              <a:t>A05: Animate equal-status bars for the base and four component configurations using the five-task mean success from the submitted paper. This is an aggregate comparison, not a learning curve.</a:t>
+              <a:t>A05: First nine seconds: LIBERO and robomimic human demonstration replays, then DMC with a scripted controller. Remaining twenty-one seconds: the unchanged measured five-task LIBERO component comparison. Task footage illustrates the environments.</a:t>
             </a:r>
           </a:p>
           <a:p/>
@@ -1257,7 +1675,7 @@
           <a:lstStyle/>
           <a:p>
             <a:r>
-              <a:t>02:00–02:16 | 16 seconds</a:t>
+              <a:t>01:36–01:52 | 16 seconds</a:t>
             </a:r>
           </a:p>
           <a:p/>
@@ -1268,7 +1686,60 @@
           </a:p>
           <a:p>
             <a:r>
-              <a:t>We evaluate OpenArm with chest and wrist cameras, joint state, and a parallel gripper. A flow-matching policy predicts action chunks. Refinement trains offline on recorded successes and failures, then we evaluate placement and stacking autonomously on a staircase scene.</a:t>
+              <a:t>We then bring CAST to OpenArm, using chest and wrist cameras. Its flow-matching policy predicts short action sequences. We refine that policy offline, using recorded successes and failures, before testing autonomous placement and stacking.</a:t>
+            </a:r>
+          </a:p>
+          <a:p/>
+          <a:p>
+            <a:r>
+              <a:t>TIMED DELIVERY CUES (DIRECTIONS ARE NOT SPOKEN)</a:t>
+            </a:r>
+          </a:p>
+          <a:p>
+            <a:r>
+              <a:t>01:36–01:41</a:t>
+            </a:r>
+          </a:p>
+          <a:p>
+            <a:r>
+              <a:t>ON SCREEN: OpenArm scene and chest/wrist camera views.</a:t>
+            </a:r>
+          </a:p>
+          <a:p>
+            <a:r>
+              <a:t>SAY: We then bring CAST to OpenArm, using chest and wrist cameras.</a:t>
+            </a:r>
+          </a:p>
+          <a:p/>
+          <a:p>
+            <a:r>
+              <a:t>01:41–01:45</a:t>
+            </a:r>
+          </a:p>
+          <a:p>
+            <a:r>
+              <a:t>ON SCREEN: Policy block: a flow policy plus residual predicts action chunks.</a:t>
+            </a:r>
+          </a:p>
+          <a:p>
+            <a:r>
+              <a:t>SAY: Its flow-matching policy predicts short action sequences.</a:t>
+            </a:r>
+          </a:p>
+          <a:p/>
+          <a:p>
+            <a:r>
+              <a:t>01:45–01:52</a:t>
+            </a:r>
+          </a:p>
+          <a:p>
+            <a:r>
+              <a:t>ON SCREEN: Follow the recorded rollouts → offline refinement → autonomous evaluation diagram.</a:t>
+            </a:r>
+          </a:p>
+          <a:p>
+            <a:r>
+              <a:t>SAY: We refine that policy offline, using recorded successes and failures, before testing autonomous placement and stacking.</a:t>
             </a:r>
           </a:p>
           <a:p/>
@@ -1365,7 +1836,7 @@
           <a:lstStyle/>
           <a:p>
             <a:r>
-              <a:t>02:16–02:32 | 16 seconds</a:t>
+              <a:t>01:52–02:08 | 16 seconds</a:t>
             </a:r>
           </a:p>
           <a:p/>
@@ -1376,7 +1847,60 @@
           </a:p>
           <a:p>
             <a:r>
-              <a:t>Placement requires putting the toy fully inside the case. CAST raises success from fifty-five to ninety-five percent, compared with eighty percent for BC refinement and ninety percent for DICE-RL, all starting from the same base.</a:t>
+              <a:t>In placement, the robot must put the toy fully inside the case. CAST increases success from fifty-five percent to ninety-five percent. That’s higher than behavior cloning and DICE-RL refinement.</a:t>
+            </a:r>
+          </a:p>
+          <a:p/>
+          <a:p>
+            <a:r>
+              <a:t>TIMED DELIVERY CUES (DIRECTIONS ARE NOT SPOKEN)</a:t>
+            </a:r>
+          </a:p>
+          <a:p>
+            <a:r>
+              <a:t>01:52–01:57</a:t>
+            </a:r>
+          </a:p>
+          <a:p>
+            <a:r>
+              <a:t>ON SCREEN: Placement task illustration; autonomous footage slot V01 currently contains a labeled demonstration still.</a:t>
+            </a:r>
+          </a:p>
+          <a:p>
+            <a:r>
+              <a:t>SAY: In placement, the robot must put the toy fully inside the case.</a:t>
+            </a:r>
+          </a:p>
+          <a:p/>
+          <a:p>
+            <a:r>
+              <a:t>01:57–02:03</a:t>
+            </a:r>
+          </a:p>
+          <a:p>
+            <a:r>
+              <a:t>ON SCREEN: Read base 55% and CAST 95% bars; leave a short pause around the percentages.</a:t>
+            </a:r>
+          </a:p>
+          <a:p>
+            <a:r>
+              <a:t>SAY: CAST increases success from fifty-five percent to ninety-five percent.</a:t>
+            </a:r>
+          </a:p>
+          <a:p/>
+          <a:p>
+            <a:r>
+              <a:t>02:03–02:08</a:t>
+            </a:r>
+          </a:p>
+          <a:p>
+            <a:r>
+              <a:t>ON SCREEN: BC 80% and DICE-RL 90% remain visible; do not read every number.</a:t>
+            </a:r>
+          </a:p>
+          <a:p>
+            <a:r>
+              <a:t>SAY: That’s higher than behavior cloning and DICE-RL refinement.</a:t>
             </a:r>
           </a:p>
           <a:p/>
@@ -1473,7 +1997,7 @@
           <a:lstStyle/>
           <a:p>
             <a:r>
-              <a:t>02:32–02:52 | 20 seconds</a:t>
+              <a:t>02:08–02:28 | 20 seconds</a:t>
             </a:r>
           </a:p>
           <a:p/>
@@ -1484,7 +2008,60 @@
           </a:p>
           <a:p>
             <a:r>
-              <a:t>Stacking requires alignment and a clean release. A common observed failure is reaching the correct position without releasing the cube. The failed outcome does not mean every preceding action was wrong. CAST reaches seventy percent success, versus thirty-five for the base, sixty-five for BC refinement, and sixty for DICE-RL.</a:t>
+              <a:t>Stacking adds another challenge: a correct approach can still end in a failed release. With sparse rewards, that final failure makes the earlier actions harder to judge. Here, CAST increases success from thirty-five to seventy percent, again exceeding both refinement baselines.</a:t>
+            </a:r>
+          </a:p>
+          <a:p/>
+          <a:p>
+            <a:r>
+              <a:t>TIMED DELIVERY CUES (DIRECTIONS ARE NOT SPOKEN)</a:t>
+            </a:r>
+          </a:p>
+          <a:p>
+            <a:r>
+              <a:t>02:08–02:15</a:t>
+            </a:r>
+          </a:p>
+          <a:p>
+            <a:r>
+              <a:t>ON SCREEN: Stacking task illustration; V02 currently contains a labeled demonstration still. Explain the observed release failure.</a:t>
+            </a:r>
+          </a:p>
+          <a:p>
+            <a:r>
+              <a:t>SAY: Stacking adds another challenge: a correct approach can still end in a failed release.</a:t>
+            </a:r>
+          </a:p>
+          <a:p/>
+          <a:p>
+            <a:r>
+              <a:t>02:15–02:21</a:t>
+            </a:r>
+          </a:p>
+          <a:p>
+            <a:r>
+              <a:t>ON SCREEN: Connect the release failure to sparse-reward credit assignment; this is an interpretation, not a separate measured result.</a:t>
+            </a:r>
+          </a:p>
+          <a:p>
+            <a:r>
+              <a:t>SAY: With sparse rewards, that final failure makes the earlier actions harder to judge.</a:t>
+            </a:r>
+          </a:p>
+          <a:p/>
+          <a:p>
+            <a:r>
+              <a:t>02:21–02:28</a:t>
+            </a:r>
+          </a:p>
+          <a:p>
+            <a:r>
+              <a:t>ON SCREEN: Read base 35% and CAST 70%; BC 65% and DICE-RL 60% remain visible.</a:t>
+            </a:r>
+          </a:p>
+          <a:p>
+            <a:r>
+              <a:t>SAY: Here, CAST increases success from thirty-five to seventy percent, again exceeding both refinement baselines.</a:t>
             </a:r>
           </a:p>
           <a:p/>
@@ -5140,7 +5717,7 @@
         <p:spPr>
           <a:xfrm>
             <a:off x="0" y="6807200"/>
-            <a:ext cx="677333" cy="50800"/>
+            <a:ext cx="468923" cy="50800"/>
           </a:xfrm>
           <a:prstGeom prst="rect">
             <a:avLst/>
@@ -5179,7 +5756,7 @@
   <p:clrMapOvr>
     <a:masterClrMapping/>
   </p:clrMapOvr>
-  <p:transition advClick="1" advTm="10000"/>
+  <p:transition advClick="1" advTm="6000"/>
 </p:sld>
 </file>
 
@@ -8734,7 +9311,7 @@
         <p:spPr>
           <a:xfrm>
             <a:off x="0" y="6807200"/>
-            <a:ext cx="2032000" cy="50800"/>
+            <a:ext cx="1406769" cy="50800"/>
           </a:xfrm>
           <a:prstGeom prst="rect">
             <a:avLst/>
@@ -8773,7 +9350,7 @@
   <p:clrMapOvr>
     <a:masterClrMapping/>
   </p:clrMapOvr>
-  <p:transition advClick="1" advTm="20000"/>
+  <p:transition advClick="1" advTm="12000"/>
   <p:timing>
     <p:tnLst>
       <p:par>
@@ -11004,7 +11581,7 @@
         <p:spPr>
           <a:xfrm>
             <a:off x="0" y="6807200"/>
-            <a:ext cx="3048000" cy="50800"/>
+            <a:ext cx="2032000" cy="50800"/>
           </a:xfrm>
           <a:prstGeom prst="rect">
             <a:avLst/>
@@ -11043,7 +11620,7 @@
   <p:clrMapOvr>
     <a:masterClrMapping/>
   </p:clrMapOvr>
-  <p:transition advClick="1" advTm="15000"/>
+  <p:transition advClick="1" advTm="8000"/>
   <p:timing>
     <p:tnLst>
       <p:par>
@@ -11127,7 +11704,7 @@
                 </a:solidFill>
                 <a:latin typeface="DejaVu Sans"/>
               </a:rPr>
-              <a:t>CONSTRUCT THE TARGET</a:t>
+              <a:t>METHOD AND EQUATIONS</a:t>
             </a:r>
           </a:p>
         </p:txBody>
@@ -11217,625 +11794,25 @@
                 </a:solidFill>
                 <a:latin typeface="DejaVu Sans"/>
               </a:rPr>
-              <a:t>Propose. Restore. Limit the step.</a:t>
-            </a:r>
-          </a:p>
-        </p:txBody>
-      </p:sp>
-      <p:sp>
-        <p:nvSpPr>
-          <p:cNvPr id="5" name="S04_004"/>
+              <a:t>CAST in four steps: animated Figure 2.</a:t>
+            </a:r>
+          </a:p>
+        </p:txBody>
+      </p:sp>
+      <p:sp>
+        <p:nvSpPr>
+          <p:cNvPr id="5" name="MEDIA_A03_FRAME"/>
           <p:cNvSpPr/>
           <p:nvPr/>
         </p:nvSpPr>
         <p:spPr>
           <a:xfrm>
-            <a:off x="546100" y="1955800"/>
-            <a:ext cx="3479800" cy="1130300"/>
+            <a:off x="0" y="0"/>
+            <a:ext cx="12192000" cy="6858000"/>
           </a:xfrm>
           <a:prstGeom prst="roundRect">
             <a:avLst>
-              <a:gd name="adj" fmla="val 7865"/>
-            </a:avLst>
-          </a:prstGeom>
-          <a:solidFill>
-            <a:srgbClr val="16273B"/>
-          </a:solidFill>
-          <a:ln>
-            <a:noFill/>
-          </a:ln>
-        </p:spPr>
-        <p:style>
-          <a:lnRef idx="1">
-            <a:schemeClr val="accent1"/>
-          </a:lnRef>
-          <a:fillRef idx="3">
-            <a:schemeClr val="accent1"/>
-          </a:fillRef>
-          <a:effectRef idx="2">
-            <a:schemeClr val="accent1"/>
-          </a:effectRef>
-          <a:fontRef idx="minor">
-            <a:schemeClr val="lt1"/>
-          </a:fontRef>
-        </p:style>
-        <p:txBody>
-          <a:bodyPr rtlCol="0" anchor="ctr"/>
-          <a:lstStyle/>
-          <a:p>
-            <a:pPr algn="ctr"/>
-          </a:p>
-        </p:txBody>
-      </p:sp>
-      <p:sp>
-        <p:nvSpPr>
-          <p:cNvPr id="6" name="S04_005"/>
-          <p:cNvSpPr/>
-          <p:nvPr/>
-        </p:nvSpPr>
-        <p:spPr>
-          <a:xfrm>
-            <a:off x="546100" y="1955800"/>
-            <a:ext cx="50800" cy="1130300"/>
-          </a:xfrm>
-          <a:prstGeom prst="rect">
-            <a:avLst/>
-          </a:prstGeom>
-          <a:solidFill>
-            <a:srgbClr val="F0B360"/>
-          </a:solidFill>
-          <a:ln>
-            <a:noFill/>
-          </a:ln>
-        </p:spPr>
-        <p:style>
-          <a:lnRef idx="1">
-            <a:schemeClr val="accent1"/>
-          </a:lnRef>
-          <a:fillRef idx="3">
-            <a:schemeClr val="accent1"/>
-          </a:fillRef>
-          <a:effectRef idx="2">
-            <a:schemeClr val="accent1"/>
-          </a:effectRef>
-          <a:fontRef idx="minor">
-            <a:schemeClr val="lt1"/>
-          </a:fontRef>
-        </p:style>
-        <p:txBody>
-          <a:bodyPr rtlCol="0" anchor="ctr"/>
-          <a:lstStyle/>
-          <a:p>
-            <a:pPr algn="ctr"/>
-          </a:p>
-        </p:txBody>
-      </p:sp>
-      <p:sp>
-        <p:nvSpPr>
-          <p:cNvPr id="7" name="S04_006"/>
-          <p:cNvSpPr txBox="1"/>
-          <p:nvPr/>
-        </p:nvSpPr>
-        <p:spPr>
-          <a:xfrm>
-            <a:off x="749300" y="2108200"/>
-            <a:ext cx="3073400" cy="342900"/>
-          </a:xfrm>
-          <a:prstGeom prst="rect">
-            <a:avLst/>
-          </a:prstGeom>
-          <a:noFill/>
-        </p:spPr>
-        <p:txBody>
-          <a:bodyPr wrap="none" lIns="0" rIns="0" tIns="0" bIns="0" anchor="t">
-            <a:spAutoFit/>
-          </a:bodyPr>
-          <a:lstStyle/>
-          <a:p>
-            <a:pPr algn="l">
-              <a:lnSpc>
-                <a:spcPts val="2106"/>
-              </a:lnSpc>
-              <a:spcBef>
-                <a:spcPts val="0"/>
-              </a:spcBef>
-              <a:spcAft>
-                <a:spcPts val="0"/>
-              </a:spcAft>
-            </a:pPr>
-            <a:r>
-              <a:rPr sz="1800" b="1">
-                <a:solidFill>
-                  <a:srgbClr val="F0B360"/>
-                </a:solidFill>
-                <a:latin typeface="DejaVu Sans"/>
-              </a:rPr>
-              <a:t>1 Critic guidance</a:t>
-            </a:r>
-          </a:p>
-        </p:txBody>
-      </p:sp>
-      <p:sp>
-        <p:nvSpPr>
-          <p:cNvPr id="8" name="S04_007"/>
-          <p:cNvSpPr txBox="1"/>
-          <p:nvPr/>
-        </p:nvSpPr>
-        <p:spPr>
-          <a:xfrm>
-            <a:off x="749300" y="2489200"/>
-            <a:ext cx="3073400" cy="533400"/>
-          </a:xfrm>
-          <a:prstGeom prst="rect">
-            <a:avLst/>
-          </a:prstGeom>
-          <a:noFill/>
-        </p:spPr>
-        <p:txBody>
-          <a:bodyPr wrap="none" lIns="0" rIns="0" tIns="0" bIns="0" anchor="t">
-            <a:spAutoFit/>
-          </a:bodyPr>
-          <a:lstStyle/>
-          <a:p>
-            <a:pPr algn="l">
-              <a:lnSpc>
-                <a:spcPts val="1638"/>
-              </a:lnSpc>
-              <a:spcBef>
-                <a:spcPts val="0"/>
-              </a:spcBef>
-              <a:spcAft>
-                <a:spcPts val="0"/>
-              </a:spcAft>
-            </a:pPr>
-            <a:r>
-              <a:rPr sz="1400" b="0">
-                <a:solidFill>
-                  <a:srgbClr val="AFBDD0"/>
-                </a:solidFill>
-                <a:latin typeface="DejaVu Sans"/>
-              </a:rPr>
-              <a:t>Normalize and cap the proposal;</a:t>
-            </a:r>
-          </a:p>
-          <a:p>
-            <a:pPr algn="l">
-              <a:lnSpc>
-                <a:spcPts val="1638"/>
-              </a:lnSpc>
-              <a:spcBef>
-                <a:spcPts val="0"/>
-              </a:spcBef>
-              <a:spcAft>
-                <a:spcPts val="0"/>
-              </a:spcAft>
-            </a:pPr>
-            <a:r>
-              <a:rPr sz="1400" b="0">
-                <a:solidFill>
-                  <a:srgbClr val="AFBDD0"/>
-                </a:solidFill>
-                <a:latin typeface="DejaVu Sans"/>
-              </a:rPr>
-              <a:t>then scale it.</a:t>
-            </a:r>
-          </a:p>
-        </p:txBody>
-      </p:sp>
-      <p:sp>
-        <p:nvSpPr>
-          <p:cNvPr id="9" name="S04_008"/>
-          <p:cNvSpPr/>
-          <p:nvPr/>
-        </p:nvSpPr>
-        <p:spPr>
-          <a:xfrm>
-            <a:off x="546100" y="3263900"/>
-            <a:ext cx="3479800" cy="1219200"/>
-          </a:xfrm>
-          <a:prstGeom prst="roundRect">
-            <a:avLst>
-              <a:gd name="adj" fmla="val 7291"/>
-            </a:avLst>
-          </a:prstGeom>
-          <a:solidFill>
-            <a:srgbClr val="16273B"/>
-          </a:solidFill>
-          <a:ln>
-            <a:noFill/>
-          </a:ln>
-        </p:spPr>
-        <p:style>
-          <a:lnRef idx="1">
-            <a:schemeClr val="accent1"/>
-          </a:lnRef>
-          <a:fillRef idx="3">
-            <a:schemeClr val="accent1"/>
-          </a:fillRef>
-          <a:effectRef idx="2">
-            <a:schemeClr val="accent1"/>
-          </a:effectRef>
-          <a:fontRef idx="minor">
-            <a:schemeClr val="lt1"/>
-          </a:fontRef>
-        </p:style>
-        <p:txBody>
-          <a:bodyPr rtlCol="0" anchor="ctr"/>
-          <a:lstStyle/>
-          <a:p>
-            <a:pPr algn="ctr"/>
-          </a:p>
-        </p:txBody>
-      </p:sp>
-      <p:sp>
-        <p:nvSpPr>
-          <p:cNvPr id="10" name="S04_009"/>
-          <p:cNvSpPr/>
-          <p:nvPr/>
-        </p:nvSpPr>
-        <p:spPr>
-          <a:xfrm>
-            <a:off x="546100" y="3263900"/>
-            <a:ext cx="50800" cy="1219200"/>
-          </a:xfrm>
-          <a:prstGeom prst="rect">
-            <a:avLst/>
-          </a:prstGeom>
-          <a:solidFill>
-            <a:srgbClr val="42D7B4"/>
-          </a:solidFill>
-          <a:ln>
-            <a:noFill/>
-          </a:ln>
-        </p:spPr>
-        <p:style>
-          <a:lnRef idx="1">
-            <a:schemeClr val="accent1"/>
-          </a:lnRef>
-          <a:fillRef idx="3">
-            <a:schemeClr val="accent1"/>
-          </a:fillRef>
-          <a:effectRef idx="2">
-            <a:schemeClr val="accent1"/>
-          </a:effectRef>
-          <a:fontRef idx="minor">
-            <a:schemeClr val="lt1"/>
-          </a:fontRef>
-        </p:style>
-        <p:txBody>
-          <a:bodyPr rtlCol="0" anchor="ctr"/>
-          <a:lstStyle/>
-          <a:p>
-            <a:pPr algn="ctr"/>
-          </a:p>
-        </p:txBody>
-      </p:sp>
-      <p:sp>
-        <p:nvSpPr>
-          <p:cNvPr id="11" name="S04_010"/>
-          <p:cNvSpPr txBox="1"/>
-          <p:nvPr/>
-        </p:nvSpPr>
-        <p:spPr>
-          <a:xfrm>
-            <a:off x="749300" y="3416300"/>
-            <a:ext cx="3073400" cy="342900"/>
-          </a:xfrm>
-          <a:prstGeom prst="rect">
-            <a:avLst/>
-          </a:prstGeom>
-          <a:noFill/>
-        </p:spPr>
-        <p:txBody>
-          <a:bodyPr wrap="none" lIns="0" rIns="0" tIns="0" bIns="0" anchor="t">
-            <a:spAutoFit/>
-          </a:bodyPr>
-          <a:lstStyle/>
-          <a:p>
-            <a:pPr algn="l">
-              <a:lnSpc>
-                <a:spcPts val="2106"/>
-              </a:lnSpc>
-              <a:spcBef>
-                <a:spcPts val="0"/>
-              </a:spcBef>
-              <a:spcAft>
-                <a:spcPts val="0"/>
-              </a:spcAft>
-            </a:pPr>
-            <a:r>
-              <a:rPr sz="1800" b="1">
-                <a:solidFill>
-                  <a:srgbClr val="42D7B4"/>
-                </a:solidFill>
-                <a:latin typeface="DejaVu Sans"/>
-              </a:rPr>
-              <a:t>2 Restoration</a:t>
-            </a:r>
-          </a:p>
-        </p:txBody>
-      </p:sp>
-      <p:sp>
-        <p:nvSpPr>
-          <p:cNvPr id="12" name="S04_011"/>
-          <p:cNvSpPr txBox="1"/>
-          <p:nvPr/>
-        </p:nvSpPr>
-        <p:spPr>
-          <a:xfrm>
-            <a:off x="749300" y="3797300"/>
-            <a:ext cx="3073400" cy="622300"/>
-          </a:xfrm>
-          <a:prstGeom prst="rect">
-            <a:avLst/>
-          </a:prstGeom>
-          <a:noFill/>
-        </p:spPr>
-        <p:txBody>
-          <a:bodyPr wrap="none" lIns="0" rIns="0" tIns="0" bIns="0" anchor="t">
-            <a:spAutoFit/>
-          </a:bodyPr>
-          <a:lstStyle/>
-          <a:p>
-            <a:pPr algn="l">
-              <a:lnSpc>
-                <a:spcPts val="1638"/>
-              </a:lnSpc>
-              <a:spcBef>
-                <a:spcPts val="0"/>
-              </a:spcBef>
-              <a:spcAft>
-                <a:spcPts val="0"/>
-              </a:spcAft>
-            </a:pPr>
-            <a:r>
-              <a:rPr sz="1400" b="0">
-                <a:solidFill>
-                  <a:srgbClr val="AFBDD0"/>
-                </a:solidFill>
-                <a:latin typeface="DejaVu Sans"/>
-              </a:rPr>
-              <a:t>Weak pull + stronger pull beyond</a:t>
-            </a:r>
-          </a:p>
-          <a:p>
-            <a:pPr algn="l">
-              <a:lnSpc>
-                <a:spcPts val="1638"/>
-              </a:lnSpc>
-              <a:spcBef>
-                <a:spcPts val="0"/>
-              </a:spcBef>
-              <a:spcAft>
-                <a:spcPts val="0"/>
-              </a:spcAft>
-            </a:pPr>
-            <a:r>
-              <a:rPr sz="1400" b="0">
-                <a:solidFill>
-                  <a:srgbClr val="AFBDD0"/>
-                </a:solidFill>
-                <a:latin typeface="DejaVu Sans"/>
-              </a:rPr>
-              <a:t>the reference radius.</a:t>
-            </a:r>
-          </a:p>
-        </p:txBody>
-      </p:sp>
-      <p:sp>
-        <p:nvSpPr>
-          <p:cNvPr id="13" name="S04_012"/>
-          <p:cNvSpPr/>
-          <p:nvPr/>
-        </p:nvSpPr>
-        <p:spPr>
-          <a:xfrm>
-            <a:off x="546100" y="4660900"/>
-            <a:ext cx="3479800" cy="1206500"/>
-          </a:xfrm>
-          <a:prstGeom prst="roundRect">
-            <a:avLst>
-              <a:gd name="adj" fmla="val 7368"/>
-            </a:avLst>
-          </a:prstGeom>
-          <a:solidFill>
-            <a:srgbClr val="16273B"/>
-          </a:solidFill>
-          <a:ln>
-            <a:noFill/>
-          </a:ln>
-        </p:spPr>
-        <p:style>
-          <a:lnRef idx="1">
-            <a:schemeClr val="accent1"/>
-          </a:lnRef>
-          <a:fillRef idx="3">
-            <a:schemeClr val="accent1"/>
-          </a:fillRef>
-          <a:effectRef idx="2">
-            <a:schemeClr val="accent1"/>
-          </a:effectRef>
-          <a:fontRef idx="minor">
-            <a:schemeClr val="lt1"/>
-          </a:fontRef>
-        </p:style>
-        <p:txBody>
-          <a:bodyPr rtlCol="0" anchor="ctr"/>
-          <a:lstStyle/>
-          <a:p>
-            <a:pPr algn="ctr"/>
-          </a:p>
-        </p:txBody>
-      </p:sp>
-      <p:sp>
-        <p:nvSpPr>
-          <p:cNvPr id="14" name="S04_013"/>
-          <p:cNvSpPr/>
-          <p:nvPr/>
-        </p:nvSpPr>
-        <p:spPr>
-          <a:xfrm>
-            <a:off x="546100" y="4660900"/>
-            <a:ext cx="50800" cy="1206500"/>
-          </a:xfrm>
-          <a:prstGeom prst="rect">
-            <a:avLst/>
-          </a:prstGeom>
-          <a:solidFill>
-            <a:srgbClr val="7FB0ED"/>
-          </a:solidFill>
-          <a:ln>
-            <a:noFill/>
-          </a:ln>
-        </p:spPr>
-        <p:style>
-          <a:lnRef idx="1">
-            <a:schemeClr val="accent1"/>
-          </a:lnRef>
-          <a:fillRef idx="3">
-            <a:schemeClr val="accent1"/>
-          </a:fillRef>
-          <a:effectRef idx="2">
-            <a:schemeClr val="accent1"/>
-          </a:effectRef>
-          <a:fontRef idx="minor">
-            <a:schemeClr val="lt1"/>
-          </a:fontRef>
-        </p:style>
-        <p:txBody>
-          <a:bodyPr rtlCol="0" anchor="ctr"/>
-          <a:lstStyle/>
-          <a:p>
-            <a:pPr algn="ctr"/>
-          </a:p>
-        </p:txBody>
-      </p:sp>
-      <p:sp>
-        <p:nvSpPr>
-          <p:cNvPr id="15" name="S04_014"/>
-          <p:cNvSpPr txBox="1"/>
-          <p:nvPr/>
-        </p:nvSpPr>
-        <p:spPr>
-          <a:xfrm>
-            <a:off x="749300" y="4813300"/>
-            <a:ext cx="3073400" cy="342900"/>
-          </a:xfrm>
-          <a:prstGeom prst="rect">
-            <a:avLst/>
-          </a:prstGeom>
-          <a:noFill/>
-        </p:spPr>
-        <p:txBody>
-          <a:bodyPr wrap="none" lIns="0" rIns="0" tIns="0" bIns="0" anchor="t">
-            <a:spAutoFit/>
-          </a:bodyPr>
-          <a:lstStyle/>
-          <a:p>
-            <a:pPr algn="l">
-              <a:lnSpc>
-                <a:spcPts val="2106"/>
-              </a:lnSpc>
-              <a:spcBef>
-                <a:spcPts val="0"/>
-              </a:spcBef>
-              <a:spcAft>
-                <a:spcPts val="0"/>
-              </a:spcAft>
-            </a:pPr>
-            <a:r>
-              <a:rPr sz="1800" b="1">
-                <a:solidFill>
-                  <a:srgbClr val="7FB0ED"/>
-                </a:solidFill>
-                <a:latin typeface="DejaVu Sans"/>
-              </a:rPr>
-              <a:t>3 Combined cap</a:t>
-            </a:r>
-          </a:p>
-        </p:txBody>
-      </p:sp>
-      <p:sp>
-        <p:nvSpPr>
-          <p:cNvPr id="16" name="S04_015"/>
-          <p:cNvSpPr txBox="1"/>
-          <p:nvPr/>
-        </p:nvSpPr>
-        <p:spPr>
-          <a:xfrm>
-            <a:off x="749300" y="5194300"/>
-            <a:ext cx="3073400" cy="609600"/>
-          </a:xfrm>
-          <a:prstGeom prst="rect">
-            <a:avLst/>
-          </a:prstGeom>
-          <a:noFill/>
-        </p:spPr>
-        <p:txBody>
-          <a:bodyPr wrap="none" lIns="0" rIns="0" tIns="0" bIns="0" anchor="t">
-            <a:spAutoFit/>
-          </a:bodyPr>
-          <a:lstStyle/>
-          <a:p>
-            <a:pPr algn="l">
-              <a:lnSpc>
-                <a:spcPts val="1638"/>
-              </a:lnSpc>
-              <a:spcBef>
-                <a:spcPts val="0"/>
-              </a:spcBef>
-              <a:spcAft>
-                <a:spcPts val="0"/>
-              </a:spcAft>
-            </a:pPr>
-            <a:r>
-              <a:rPr sz="1400" b="0">
-                <a:solidFill>
-                  <a:srgbClr val="AFBDD0"/>
-                </a:solidFill>
-                <a:latin typeface="DejaVu Sans"/>
-              </a:rPr>
-              <a:t>Limit the final target step from</a:t>
-            </a:r>
-          </a:p>
-          <a:p>
-            <a:pPr algn="l">
-              <a:lnSpc>
-                <a:spcPts val="1638"/>
-              </a:lnSpc>
-              <a:spcBef>
-                <a:spcPts val="0"/>
-              </a:spcBef>
-              <a:spcAft>
-                <a:spcPts val="0"/>
-              </a:spcAft>
-            </a:pPr>
-            <a:r>
-              <a:rPr sz="1400" b="0">
-                <a:solidFill>
-                  <a:srgbClr val="AFBDD0"/>
-                </a:solidFill>
-                <a:latin typeface="DejaVu Sans"/>
-              </a:rPr>
-              <a:t>the current action.</a:t>
-            </a:r>
-          </a:p>
-        </p:txBody>
-      </p:sp>
-      <p:sp>
-        <p:nvSpPr>
-          <p:cNvPr id="17" name="MEDIA_A03_FRAME"/>
-          <p:cNvSpPr/>
-          <p:nvPr/>
-        </p:nvSpPr>
-        <p:spPr>
-          <a:xfrm>
-            <a:off x="4343400" y="1841500"/>
-            <a:ext cx="7315200" cy="4114800"/>
-          </a:xfrm>
-          <a:prstGeom prst="roundRect">
-            <a:avLst>
-              <a:gd name="adj" fmla="val 2469"/>
+              <a:gd name="adj" fmla="val 1481"/>
             </a:avLst>
           </a:prstGeom>
           <a:solidFill>
@@ -11871,14 +11848,14 @@
       </p:sp>
       <p:sp>
         <p:nvSpPr>
-          <p:cNvPr id="18" name="MEDIA_A03_LABEL"/>
+          <p:cNvPr id="6" name="MEDIA_A03_LABEL"/>
           <p:cNvSpPr txBox="1"/>
           <p:nvPr/>
         </p:nvSpPr>
         <p:spPr>
           <a:xfrm>
-            <a:off x="4546600" y="1993900"/>
-            <a:ext cx="6908800" cy="254000"/>
+            <a:off x="203200" y="152400"/>
+            <a:ext cx="11785600" cy="254000"/>
           </a:xfrm>
           <a:prstGeom prst="rect">
             <a:avLst/>
@@ -11909,21 +11886,21 @@
                 </a:solidFill>
                 <a:latin typeface="DejaVu Sans"/>
               </a:rPr>
-              <a:t>A03 / Construct the action target</a:t>
-            </a:r>
-          </a:p>
-        </p:txBody>
-      </p:sp>
-      <p:sp>
-        <p:nvSpPr>
-          <p:cNvPr id="19" name="MEDIA_A03_STATUS"/>
+              <a:t>A03 / Animated Figure 2: sample → propose → constrain → fit</a:t>
+            </a:r>
+          </a:p>
+        </p:txBody>
+      </p:sp>
+      <p:sp>
+        <p:nvSpPr>
+          <p:cNvPr id="7" name="MEDIA_A03_STATUS"/>
           <p:cNvSpPr txBox="1"/>
           <p:nvPr/>
         </p:nvSpPr>
         <p:spPr>
           <a:xfrm>
-            <a:off x="4546600" y="5664200"/>
-            <a:ext cx="6908800" cy="203200"/>
+            <a:off x="203200" y="6565900"/>
+            <a:ext cx="11785600" cy="203200"/>
           </a:xfrm>
           <a:prstGeom prst="rect">
             <a:avLst/>
@@ -11961,872 +11938,14 @@
       </p:sp>
       <p:sp>
         <p:nvSpPr>
-          <p:cNvPr id="20" name="S04_019"/>
+          <p:cNvPr id="8" name="MEDIA_A03_MASK"/>
           <p:cNvSpPr/>
           <p:nvPr/>
         </p:nvSpPr>
         <p:spPr>
           <a:xfrm>
-            <a:off x="4787900" y="3556000"/>
-            <a:ext cx="1651000" cy="1651000"/>
-          </a:xfrm>
-          <a:prstGeom prst="ellipse">
-            <a:avLst/>
-          </a:prstGeom>
-          <a:noFill/>
-          <a:ln w="12700">
-            <a:solidFill>
-              <a:srgbClr val="7FB0ED"/>
-            </a:solidFill>
-          </a:ln>
-        </p:spPr>
-        <p:style>
-          <a:lnRef idx="1">
-            <a:schemeClr val="accent1"/>
-          </a:lnRef>
-          <a:fillRef idx="3">
-            <a:schemeClr val="accent1"/>
-          </a:fillRef>
-          <a:effectRef idx="2">
-            <a:schemeClr val="accent1"/>
-          </a:effectRef>
-          <a:fontRef idx="minor">
-            <a:schemeClr val="lt1"/>
-          </a:fontRef>
-        </p:style>
-        <p:txBody>
-          <a:bodyPr rtlCol="0" anchor="ctr"/>
-          <a:lstStyle/>
-          <a:p>
-            <a:pPr algn="ctr"/>
-          </a:p>
-        </p:txBody>
-      </p:sp>
-      <p:sp>
-        <p:nvSpPr>
-          <p:cNvPr id="21" name="S04_020"/>
-          <p:cNvSpPr/>
-          <p:nvPr/>
-        </p:nvSpPr>
-        <p:spPr>
-          <a:xfrm>
-            <a:off x="6654800" y="2997200"/>
-            <a:ext cx="1524000" cy="1524000"/>
-          </a:xfrm>
-          <a:prstGeom prst="ellipse">
-            <a:avLst/>
-          </a:prstGeom>
-          <a:noFill/>
-          <a:ln w="12700">
-            <a:solidFill>
-              <a:srgbClr val="AFBDD0"/>
-            </a:solidFill>
-          </a:ln>
-        </p:spPr>
-        <p:style>
-          <a:lnRef idx="1">
-            <a:schemeClr val="accent1"/>
-          </a:lnRef>
-          <a:fillRef idx="3">
-            <a:schemeClr val="accent1"/>
-          </a:fillRef>
-          <a:effectRef idx="2">
-            <a:schemeClr val="accent1"/>
-          </a:effectRef>
-          <a:fontRef idx="minor">
-            <a:schemeClr val="lt1"/>
-          </a:fontRef>
-        </p:style>
-        <p:txBody>
-          <a:bodyPr rtlCol="0" anchor="ctr"/>
-          <a:lstStyle/>
-          <a:p>
-            <a:pPr algn="ctr"/>
-          </a:p>
-        </p:txBody>
-      </p:sp>
-      <p:sp>
-        <p:nvSpPr>
-          <p:cNvPr id="22" name="S04_021"/>
-          <p:cNvSpPr/>
-          <p:nvPr/>
-        </p:nvSpPr>
-        <p:spPr>
-          <a:xfrm>
-            <a:off x="5537200" y="4305300"/>
-            <a:ext cx="152400" cy="152400"/>
-          </a:xfrm>
-          <a:prstGeom prst="ellipse">
-            <a:avLst/>
-          </a:prstGeom>
-          <a:solidFill>
-            <a:srgbClr val="7FB0ED"/>
-          </a:solidFill>
-          <a:ln>
-            <a:noFill/>
-          </a:ln>
-        </p:spPr>
-        <p:style>
-          <a:lnRef idx="1">
-            <a:schemeClr val="accent1"/>
-          </a:lnRef>
-          <a:fillRef idx="3">
-            <a:schemeClr val="accent1"/>
-          </a:fillRef>
-          <a:effectRef idx="2">
-            <a:schemeClr val="accent1"/>
-          </a:effectRef>
-          <a:fontRef idx="minor">
-            <a:schemeClr val="lt1"/>
-          </a:fontRef>
-        </p:style>
-        <p:txBody>
-          <a:bodyPr rtlCol="0" anchor="ctr"/>
-          <a:lstStyle/>
-          <a:p>
-            <a:pPr algn="ctr"/>
-          </a:p>
-        </p:txBody>
-      </p:sp>
-      <p:sp>
-        <p:nvSpPr>
-          <p:cNvPr id="23" name="S04_022"/>
-          <p:cNvSpPr/>
-          <p:nvPr/>
-        </p:nvSpPr>
-        <p:spPr>
-          <a:xfrm>
-            <a:off x="7340600" y="3683000"/>
-            <a:ext cx="152400" cy="152400"/>
-          </a:xfrm>
-          <a:prstGeom prst="ellipse">
-            <a:avLst/>
-          </a:prstGeom>
-          <a:solidFill>
-            <a:srgbClr val="8D9BAC"/>
-          </a:solidFill>
-          <a:ln>
-            <a:noFill/>
-          </a:ln>
-        </p:spPr>
-        <p:style>
-          <a:lnRef idx="1">
-            <a:schemeClr val="accent1"/>
-          </a:lnRef>
-          <a:fillRef idx="3">
-            <a:schemeClr val="accent1"/>
-          </a:fillRef>
-          <a:effectRef idx="2">
-            <a:schemeClr val="accent1"/>
-          </a:effectRef>
-          <a:fontRef idx="minor">
-            <a:schemeClr val="lt1"/>
-          </a:fontRef>
-        </p:style>
-        <p:txBody>
-          <a:bodyPr rtlCol="0" anchor="ctr"/>
-          <a:lstStyle/>
-          <a:p>
-            <a:pPr algn="ctr"/>
-          </a:p>
-        </p:txBody>
-      </p:sp>
-      <p:cxnSp>
-        <p:nvCxnSpPr>
-          <p:cNvPr id="24" name="S04_023"/>
-          <p:cNvCxnSpPr/>
-          <p:nvPr/>
-        </p:nvCxnSpPr>
-        <p:spPr>
-          <a:xfrm flipV="1">
-            <a:off x="5613400" y="3759200"/>
-            <a:ext cx="1803400" cy="622300"/>
-          </a:xfrm>
-          <a:prstGeom prst="line">
-            <a:avLst/>
-          </a:prstGeom>
-          <a:ln w="12700">
-            <a:solidFill>
-              <a:srgbClr val="7FB0ED"/>
-            </a:solidFill>
-            <a:prstDash val="dash"/>
-          </a:ln>
-        </p:spPr>
-        <p:style>
-          <a:lnRef idx="2">
-            <a:schemeClr val="accent1"/>
-          </a:lnRef>
-          <a:fillRef idx="0">
-            <a:schemeClr val="accent1"/>
-          </a:fillRef>
-          <a:effectRef idx="1">
-            <a:schemeClr val="accent1"/>
-          </a:effectRef>
-          <a:fontRef idx="minor">
-            <a:schemeClr val="tx1"/>
-          </a:fontRef>
-        </p:style>
-      </p:cxnSp>
-      <p:cxnSp>
-        <p:nvCxnSpPr>
-          <p:cNvPr id="25" name="S04_024"/>
-          <p:cNvCxnSpPr/>
-          <p:nvPr/>
-        </p:nvCxnSpPr>
-        <p:spPr>
-          <a:xfrm flipV="1">
-            <a:off x="7416800" y="2959100"/>
-            <a:ext cx="2057400" cy="800100"/>
-          </a:xfrm>
-          <a:prstGeom prst="line">
-            <a:avLst/>
-          </a:prstGeom>
-          <a:ln w="38100">
-            <a:solidFill>
-              <a:srgbClr val="F0B360"/>
-            </a:solidFill>
-          </a:ln>
-        </p:spPr>
-        <p:style>
-          <a:lnRef idx="2">
-            <a:schemeClr val="accent1"/>
-          </a:lnRef>
-          <a:fillRef idx="0">
-            <a:schemeClr val="accent1"/>
-          </a:fillRef>
-          <a:effectRef idx="1">
-            <a:schemeClr val="accent1"/>
-          </a:effectRef>
-          <a:fontRef idx="minor">
-            <a:schemeClr val="tx1"/>
-          </a:fontRef>
-        </p:style>
-      </p:cxnSp>
-      <p:cxnSp>
-        <p:nvCxnSpPr>
-          <p:cNvPr id="26" name="S04_025"/>
-          <p:cNvCxnSpPr/>
-          <p:nvPr/>
-        </p:nvCxnSpPr>
-        <p:spPr>
-          <a:xfrm flipH="1">
-            <a:off x="9404952" y="2959100"/>
-            <a:ext cx="69248" cy="74346"/>
-          </a:xfrm>
-          <a:prstGeom prst="line">
-            <a:avLst/>
-          </a:prstGeom>
-          <a:ln w="38100">
-            <a:solidFill>
-              <a:srgbClr val="F0B360"/>
-            </a:solidFill>
-          </a:ln>
-        </p:spPr>
-        <p:style>
-          <a:lnRef idx="2">
-            <a:schemeClr val="accent1"/>
-          </a:lnRef>
-          <a:fillRef idx="0">
-            <a:schemeClr val="accent1"/>
-          </a:fillRef>
-          <a:effectRef idx="1">
-            <a:schemeClr val="accent1"/>
-          </a:effectRef>
-          <a:fontRef idx="minor">
-            <a:schemeClr val="tx1"/>
-          </a:fontRef>
-        </p:style>
-      </p:cxnSp>
-      <p:cxnSp>
-        <p:nvCxnSpPr>
-          <p:cNvPr id="27" name="S04_026"/>
-          <p:cNvCxnSpPr/>
-          <p:nvPr/>
-        </p:nvCxnSpPr>
-        <p:spPr>
-          <a:xfrm flipH="1" flipV="1">
-            <a:off x="9372917" y="2951070"/>
-            <a:ext cx="101283" cy="8030"/>
-          </a:xfrm>
-          <a:prstGeom prst="line">
-            <a:avLst/>
-          </a:prstGeom>
-          <a:ln w="38100">
-            <a:solidFill>
-              <a:srgbClr val="F0B360"/>
-            </a:solidFill>
-          </a:ln>
-        </p:spPr>
-        <p:style>
-          <a:lnRef idx="2">
-            <a:schemeClr val="accent1"/>
-          </a:lnRef>
-          <a:fillRef idx="0">
-            <a:schemeClr val="accent1"/>
-          </a:fillRef>
-          <a:effectRef idx="1">
-            <a:schemeClr val="accent1"/>
-          </a:effectRef>
-          <a:fontRef idx="minor">
-            <a:schemeClr val="tx1"/>
-          </a:fontRef>
-        </p:style>
-      </p:cxnSp>
-      <p:cxnSp>
-        <p:nvCxnSpPr>
-          <p:cNvPr id="28" name="S04_027"/>
-          <p:cNvCxnSpPr/>
-          <p:nvPr/>
-        </p:nvCxnSpPr>
-        <p:spPr>
-          <a:xfrm flipH="1">
-            <a:off x="8674100" y="2959100"/>
-            <a:ext cx="800100" cy="279400"/>
-          </a:xfrm>
-          <a:prstGeom prst="line">
-            <a:avLst/>
-          </a:prstGeom>
-          <a:ln w="38100">
-            <a:solidFill>
-              <a:srgbClr val="42D7B4"/>
-            </a:solidFill>
-          </a:ln>
-        </p:spPr>
-        <p:style>
-          <a:lnRef idx="2">
-            <a:schemeClr val="accent1"/>
-          </a:lnRef>
-          <a:fillRef idx="0">
-            <a:schemeClr val="accent1"/>
-          </a:fillRef>
-          <a:effectRef idx="1">
-            <a:schemeClr val="accent1"/>
-          </a:effectRef>
-          <a:fontRef idx="minor">
-            <a:schemeClr val="tx1"/>
-          </a:fontRef>
-        </p:style>
-      </p:cxnSp>
-      <p:cxnSp>
-        <p:nvCxnSpPr>
-          <p:cNvPr id="29" name="S04_028"/>
-          <p:cNvCxnSpPr/>
-          <p:nvPr/>
-        </p:nvCxnSpPr>
-        <p:spPr>
-          <a:xfrm flipV="1">
-            <a:off x="8674100" y="3166617"/>
-            <a:ext cx="71801" cy="71883"/>
-          </a:xfrm>
-          <a:prstGeom prst="line">
-            <a:avLst/>
-          </a:prstGeom>
-          <a:ln w="38100">
-            <a:solidFill>
-              <a:srgbClr val="42D7B4"/>
-            </a:solidFill>
-          </a:ln>
-        </p:spPr>
-        <p:style>
-          <a:lnRef idx="2">
-            <a:schemeClr val="accent1"/>
-          </a:lnRef>
-          <a:fillRef idx="0">
-            <a:schemeClr val="accent1"/>
-          </a:fillRef>
-          <a:effectRef idx="1">
-            <a:schemeClr val="accent1"/>
-          </a:effectRef>
-          <a:fontRef idx="minor">
-            <a:schemeClr val="tx1"/>
-          </a:fontRef>
-        </p:style>
-      </p:cxnSp>
-      <p:cxnSp>
-        <p:nvCxnSpPr>
-          <p:cNvPr id="30" name="S04_029"/>
-          <p:cNvCxnSpPr/>
-          <p:nvPr/>
-        </p:nvCxnSpPr>
-        <p:spPr>
-          <a:xfrm>
-            <a:off x="8674100" y="3238500"/>
-            <a:ext cx="100940" cy="11560"/>
-          </a:xfrm>
-          <a:prstGeom prst="line">
-            <a:avLst/>
-          </a:prstGeom>
-          <a:ln w="38100">
-            <a:solidFill>
-              <a:srgbClr val="42D7B4"/>
-            </a:solidFill>
-          </a:ln>
-        </p:spPr>
-        <p:style>
-          <a:lnRef idx="2">
-            <a:schemeClr val="accent1"/>
-          </a:lnRef>
-          <a:fillRef idx="0">
-            <a:schemeClr val="accent1"/>
-          </a:fillRef>
-          <a:effectRef idx="1">
-            <a:schemeClr val="accent1"/>
-          </a:effectRef>
-          <a:fontRef idx="minor">
-            <a:schemeClr val="tx1"/>
-          </a:fontRef>
-        </p:style>
-      </p:cxnSp>
-      <p:cxnSp>
-        <p:nvCxnSpPr>
-          <p:cNvPr id="31" name="S04_030"/>
-          <p:cNvCxnSpPr/>
-          <p:nvPr/>
-        </p:nvCxnSpPr>
-        <p:spPr>
-          <a:xfrm flipV="1">
-            <a:off x="7416800" y="3467100"/>
-            <a:ext cx="698500" cy="292100"/>
-          </a:xfrm>
-          <a:prstGeom prst="line">
-            <a:avLst/>
-          </a:prstGeom>
-          <a:ln w="38100">
-            <a:solidFill>
-              <a:srgbClr val="42D7B4"/>
-            </a:solidFill>
-          </a:ln>
-        </p:spPr>
-        <p:style>
-          <a:lnRef idx="2">
-            <a:schemeClr val="accent1"/>
-          </a:lnRef>
-          <a:fillRef idx="0">
-            <a:schemeClr val="accent1"/>
-          </a:fillRef>
-          <a:effectRef idx="1">
-            <a:schemeClr val="accent1"/>
-          </a:effectRef>
-          <a:fontRef idx="minor">
-            <a:schemeClr val="tx1"/>
-          </a:fontRef>
-        </p:style>
-      </p:cxnSp>
-      <p:cxnSp>
-        <p:nvCxnSpPr>
-          <p:cNvPr id="32" name="S04_031"/>
-          <p:cNvCxnSpPr/>
-          <p:nvPr/>
-        </p:nvCxnSpPr>
-        <p:spPr>
-          <a:xfrm flipH="1">
-            <a:off x="8047947" y="3467100"/>
-            <a:ext cx="67353" cy="76066"/>
-          </a:xfrm>
-          <a:prstGeom prst="line">
-            <a:avLst/>
-          </a:prstGeom>
-          <a:ln w="38100">
-            <a:solidFill>
-              <a:srgbClr val="42D7B4"/>
-            </a:solidFill>
-          </a:ln>
-        </p:spPr>
-        <p:style>
-          <a:lnRef idx="2">
-            <a:schemeClr val="accent1"/>
-          </a:lnRef>
-          <a:fillRef idx="0">
-            <a:schemeClr val="accent1"/>
-          </a:fillRef>
-          <a:effectRef idx="1">
-            <a:schemeClr val="accent1"/>
-          </a:effectRef>
-          <a:fontRef idx="minor">
-            <a:schemeClr val="tx1"/>
-          </a:fontRef>
-        </p:style>
-      </p:cxnSp>
-      <p:cxnSp>
-        <p:nvCxnSpPr>
-          <p:cNvPr id="33" name="S04_032"/>
-          <p:cNvCxnSpPr/>
-          <p:nvPr/>
-        </p:nvCxnSpPr>
-        <p:spPr>
-          <a:xfrm flipH="1" flipV="1">
-            <a:off x="8013847" y="3461624"/>
-            <a:ext cx="101453" cy="5476"/>
-          </a:xfrm>
-          <a:prstGeom prst="line">
-            <a:avLst/>
-          </a:prstGeom>
-          <a:ln w="38100">
-            <a:solidFill>
-              <a:srgbClr val="42D7B4"/>
-            </a:solidFill>
-          </a:ln>
-        </p:spPr>
-        <p:style>
-          <a:lnRef idx="2">
-            <a:schemeClr val="accent1"/>
-          </a:lnRef>
-          <a:fillRef idx="0">
-            <a:schemeClr val="accent1"/>
-          </a:fillRef>
-          <a:effectRef idx="1">
-            <a:schemeClr val="accent1"/>
-          </a:effectRef>
-          <a:fontRef idx="minor">
-            <a:schemeClr val="tx1"/>
-          </a:fontRef>
-        </p:style>
-      </p:cxnSp>
-      <p:sp>
-        <p:nvSpPr>
-          <p:cNvPr id="34" name="S04_033"/>
-          <p:cNvSpPr/>
-          <p:nvPr/>
-        </p:nvSpPr>
-        <p:spPr>
-          <a:xfrm>
-            <a:off x="8026400" y="3378200"/>
-            <a:ext cx="177800" cy="177800"/>
-          </a:xfrm>
-          <a:prstGeom prst="ellipse">
-            <a:avLst/>
-          </a:prstGeom>
-          <a:solidFill>
-            <a:srgbClr val="42D7B4"/>
-          </a:solidFill>
-          <a:ln>
-            <a:noFill/>
-          </a:ln>
-        </p:spPr>
-        <p:style>
-          <a:lnRef idx="1">
-            <a:schemeClr val="accent1"/>
-          </a:lnRef>
-          <a:fillRef idx="3">
-            <a:schemeClr val="accent1"/>
-          </a:fillRef>
-          <a:effectRef idx="2">
-            <a:schemeClr val="accent1"/>
-          </a:effectRef>
-          <a:fontRef idx="minor">
-            <a:schemeClr val="lt1"/>
-          </a:fontRef>
-        </p:style>
-        <p:txBody>
-          <a:bodyPr rtlCol="0" anchor="ctr"/>
-          <a:lstStyle/>
-          <a:p>
-            <a:pPr algn="ctr"/>
-          </a:p>
-        </p:txBody>
-      </p:sp>
-      <p:sp>
-        <p:nvSpPr>
-          <p:cNvPr id="35" name="S04_034"/>
-          <p:cNvSpPr txBox="1"/>
-          <p:nvPr/>
-        </p:nvSpPr>
-        <p:spPr>
-          <a:xfrm>
-            <a:off x="4902200" y="5270500"/>
-            <a:ext cx="1524000" cy="254000"/>
-          </a:xfrm>
-          <a:prstGeom prst="rect">
-            <a:avLst/>
-          </a:prstGeom>
-          <a:noFill/>
-        </p:spPr>
-        <p:txBody>
-          <a:bodyPr wrap="none" lIns="0" rIns="0" tIns="0" bIns="0" anchor="t">
-            <a:spAutoFit/>
-          </a:bodyPr>
-          <a:lstStyle/>
-          <a:p>
-            <a:pPr algn="l">
-              <a:lnSpc>
-                <a:spcPts val="1638"/>
-              </a:lnSpc>
-              <a:spcBef>
-                <a:spcPts val="0"/>
-              </a:spcBef>
-              <a:spcAft>
-                <a:spcPts val="0"/>
-              </a:spcAft>
-            </a:pPr>
-            <a:r>
-              <a:rPr sz="1400" b="0">
-                <a:solidFill>
-                  <a:srgbClr val="7FB0ED"/>
-                </a:solidFill>
-                <a:latin typeface="DejaVu Sans"/>
-              </a:rPr>
-              <a:t>Paired base</a:t>
-            </a:r>
-          </a:p>
-        </p:txBody>
-      </p:sp>
-      <p:sp>
-        <p:nvSpPr>
-          <p:cNvPr id="36" name="S04_035"/>
-          <p:cNvSpPr txBox="1"/>
-          <p:nvPr/>
-        </p:nvSpPr>
-        <p:spPr>
-          <a:xfrm>
-            <a:off x="7099300" y="4699000"/>
-            <a:ext cx="2006600" cy="292100"/>
-          </a:xfrm>
-          <a:prstGeom prst="rect">
-            <a:avLst/>
-          </a:prstGeom>
-          <a:noFill/>
-        </p:spPr>
-        <p:txBody>
-          <a:bodyPr wrap="none" lIns="0" rIns="0" tIns="0" bIns="0" anchor="t">
-            <a:spAutoFit/>
-          </a:bodyPr>
-          <a:lstStyle/>
-          <a:p>
-            <a:pPr algn="l">
-              <a:lnSpc>
-                <a:spcPts val="1638"/>
-              </a:lnSpc>
-              <a:spcBef>
-                <a:spcPts val="0"/>
-              </a:spcBef>
-              <a:spcAft>
-                <a:spcPts val="0"/>
-              </a:spcAft>
-            </a:pPr>
-            <a:r>
-              <a:rPr sz="1400" b="0">
-                <a:solidFill>
-                  <a:srgbClr val="AFBDD0"/>
-                </a:solidFill>
-                <a:latin typeface="DejaVu Sans"/>
-              </a:rPr>
-              <a:t>Current action</a:t>
-            </a:r>
-          </a:p>
-        </p:txBody>
-      </p:sp>
-      <p:sp>
-        <p:nvSpPr>
-          <p:cNvPr id="37" name="S04_036"/>
-          <p:cNvSpPr txBox="1"/>
-          <p:nvPr/>
-        </p:nvSpPr>
-        <p:spPr>
-          <a:xfrm>
-            <a:off x="8915400" y="2463800"/>
-            <a:ext cx="2070100" cy="317500"/>
-          </a:xfrm>
-          <a:prstGeom prst="rect">
-            <a:avLst/>
-          </a:prstGeom>
-          <a:noFill/>
-        </p:spPr>
-        <p:txBody>
-          <a:bodyPr wrap="none" lIns="0" rIns="0" tIns="0" bIns="0" anchor="t">
-            <a:spAutoFit/>
-          </a:bodyPr>
-          <a:lstStyle/>
-          <a:p>
-            <a:pPr algn="l">
-              <a:lnSpc>
-                <a:spcPts val="1638"/>
-              </a:lnSpc>
-              <a:spcBef>
-                <a:spcPts val="0"/>
-              </a:spcBef>
-              <a:spcAft>
-                <a:spcPts val="0"/>
-              </a:spcAft>
-            </a:pPr>
-            <a:r>
-              <a:rPr sz="1400" b="0">
-                <a:solidFill>
-                  <a:srgbClr val="F0B360"/>
-                </a:solidFill>
-                <a:latin typeface="DejaVu Sans"/>
-              </a:rPr>
-              <a:t>Critic proposal</a:t>
-            </a:r>
-          </a:p>
-        </p:txBody>
-      </p:sp>
-      <p:sp>
-        <p:nvSpPr>
-          <p:cNvPr id="38" name="S04_037"/>
-          <p:cNvSpPr txBox="1"/>
-          <p:nvPr/>
-        </p:nvSpPr>
-        <p:spPr>
-          <a:xfrm>
-            <a:off x="9436100" y="3556000"/>
-            <a:ext cx="1905000" cy="546100"/>
-          </a:xfrm>
-          <a:prstGeom prst="rect">
-            <a:avLst/>
-          </a:prstGeom>
-          <a:noFill/>
-        </p:spPr>
-        <p:txBody>
-          <a:bodyPr wrap="none" lIns="0" rIns="0" tIns="0" bIns="0" anchor="t">
-            <a:spAutoFit/>
-          </a:bodyPr>
-          <a:lstStyle/>
-          <a:p>
-            <a:pPr algn="l">
-              <a:lnSpc>
-                <a:spcPts val="1638"/>
-              </a:lnSpc>
-              <a:spcBef>
-                <a:spcPts val="0"/>
-              </a:spcBef>
-              <a:spcAft>
-                <a:spcPts val="0"/>
-              </a:spcAft>
-            </a:pPr>
-            <a:r>
-              <a:rPr sz="1400" b="0">
-                <a:solidFill>
-                  <a:srgbClr val="42D7B4"/>
-                </a:solidFill>
-                <a:latin typeface="DejaVu Sans"/>
-              </a:rPr>
-              <a:t>Restoring</a:t>
-            </a:r>
-          </a:p>
-          <a:p>
-            <a:pPr algn="l">
-              <a:lnSpc>
-                <a:spcPts val="1638"/>
-              </a:lnSpc>
-              <a:spcBef>
-                <a:spcPts val="0"/>
-              </a:spcBef>
-              <a:spcAft>
-                <a:spcPts val="0"/>
-              </a:spcAft>
-            </a:pPr>
-            <a:r>
-              <a:rPr sz="1400" b="0">
-                <a:solidFill>
-                  <a:srgbClr val="42D7B4"/>
-                </a:solidFill>
-                <a:latin typeface="DejaVu Sans"/>
-              </a:rPr>
-              <a:t>correction</a:t>
-            </a:r>
-          </a:p>
-        </p:txBody>
-      </p:sp>
-      <p:sp>
-        <p:nvSpPr>
-          <p:cNvPr id="39" name="S04_038"/>
-          <p:cNvSpPr txBox="1"/>
-          <p:nvPr/>
-        </p:nvSpPr>
-        <p:spPr>
-          <a:xfrm>
-            <a:off x="8242300" y="4127500"/>
-            <a:ext cx="2311400" cy="317500"/>
-          </a:xfrm>
-          <a:prstGeom prst="rect">
-            <a:avLst/>
-          </a:prstGeom>
-          <a:noFill/>
-        </p:spPr>
-        <p:txBody>
-          <a:bodyPr wrap="none" lIns="0" rIns="0" tIns="0" bIns="0" anchor="t">
-            <a:spAutoFit/>
-          </a:bodyPr>
-          <a:lstStyle/>
-          <a:p>
-            <a:pPr algn="l">
-              <a:lnSpc>
-                <a:spcPts val="1754"/>
-              </a:lnSpc>
-              <a:spcBef>
-                <a:spcPts val="0"/>
-              </a:spcBef>
-              <a:spcAft>
-                <a:spcPts val="0"/>
-              </a:spcAft>
-            </a:pPr>
-            <a:r>
-              <a:rPr sz="1500" b="1">
-                <a:solidFill>
-                  <a:srgbClr val="42D7B4"/>
-                </a:solidFill>
-                <a:latin typeface="DejaVu Sans"/>
-              </a:rPr>
-              <a:t>Capped target</a:t>
-            </a:r>
-          </a:p>
-        </p:txBody>
-      </p:sp>
-      <p:sp>
-        <p:nvSpPr>
-          <p:cNvPr id="40" name="S04_039"/>
-          <p:cNvSpPr txBox="1"/>
-          <p:nvPr/>
-        </p:nvSpPr>
-        <p:spPr>
-          <a:xfrm>
-            <a:off x="4457700" y="6096000"/>
-            <a:ext cx="7086600" cy="317500"/>
-          </a:xfrm>
-          <a:prstGeom prst="rect">
-            <a:avLst/>
-          </a:prstGeom>
-          <a:noFill/>
-        </p:spPr>
-        <p:txBody>
-          <a:bodyPr wrap="none" lIns="0" rIns="0" tIns="0" bIns="0" anchor="t">
-            <a:spAutoFit/>
-          </a:bodyPr>
-          <a:lstStyle/>
-          <a:p>
-            <a:pPr algn="ctr">
-              <a:lnSpc>
-                <a:spcPts val="1521"/>
-              </a:lnSpc>
-              <a:spcBef>
-                <a:spcPts val="0"/>
-              </a:spcBef>
-              <a:spcAft>
-                <a:spcPts val="0"/>
-              </a:spcAft>
-            </a:pPr>
-            <a:r>
-              <a:rPr sz="1300" b="0">
-                <a:solidFill>
-                  <a:srgbClr val="AFBDD0"/>
-                </a:solidFill>
-                <a:latin typeface="DejaVu Sans"/>
-              </a:rPr>
-              <a:t>Targets are constrained; fitted outputs are not hard-bounded.</a:t>
-            </a:r>
-          </a:p>
-        </p:txBody>
-      </p:sp>
-      <p:sp>
-        <p:nvSpPr>
-          <p:cNvPr id="41" name="MEDIA_A03_MASK"/>
-          <p:cNvSpPr/>
-          <p:nvPr/>
-        </p:nvSpPr>
-        <p:spPr>
-          <a:xfrm>
-            <a:off x="4343400" y="1841500"/>
-            <a:ext cx="7315200" cy="4114800"/>
+            <a:off x="0" y="0"/>
+            <a:ext cx="12192000" cy="6858000"/>
           </a:xfrm>
           <a:prstGeom prst="rect">
             <a:avLst/>
@@ -12862,7 +11981,7 @@
       </p:sp>
       <p:pic>
         <p:nvPicPr>
-          <p:cNvPr id="42" name="S04_041" descr="image.png"/>
+          <p:cNvPr id="9" name="S04_008" descr="image.png"/>
           <p:cNvPicPr>
             <a:picLocks noChangeAspect="1"/>
           </p:cNvPicPr>
@@ -12876,8 +11995,8 @@
         </p:blipFill>
         <p:spPr>
           <a:xfrm>
-            <a:off x="4343400" y="1841500"/>
-            <a:ext cx="7315200" cy="4114800"/>
+            <a:off x="0" y="0"/>
+            <a:ext cx="12192000" cy="6858000"/>
           </a:xfrm>
           <a:prstGeom prst="rect">
             <a:avLst/>
@@ -12886,7 +12005,7 @@
       </p:pic>
       <p:pic>
         <p:nvPicPr>
-          <p:cNvPr id="43" name="MEDIA_A03_VIDEO">
+          <p:cNvPr id="10" name="MEDIA_A03_VIDEO">
             <a:hlinkClick r:id="" action="ppaction://media"/>
           </p:cNvPr>
           <p:cNvPicPr>
@@ -12909,8 +12028,8 @@
         </p:blipFill>
         <p:spPr>
           <a:xfrm>
-            <a:off x="4343400" y="1841500"/>
-            <a:ext cx="7315200" cy="4114800"/>
+            <a:off x="0" y="0"/>
+            <a:ext cx="12192000" cy="6858000"/>
           </a:xfrm>
           <a:prstGeom prst="rect">
             <a:avLst/>
@@ -12919,7 +12038,7 @@
       </p:pic>
       <p:sp>
         <p:nvSpPr>
-          <p:cNvPr id="44" name="S04_043"/>
+          <p:cNvPr id="11" name="S04_010"/>
           <p:cNvSpPr txBox="1"/>
           <p:nvPr/>
         </p:nvSpPr>
@@ -12964,7 +12083,7 @@
       </p:sp>
       <p:sp>
         <p:nvSpPr>
-          <p:cNvPr id="45" name="S04_044"/>
+          <p:cNvPr id="12" name="S04_011"/>
           <p:cNvSpPr txBox="1"/>
           <p:nvPr/>
         </p:nvSpPr>
@@ -13009,7 +12128,7 @@
       </p:sp>
       <p:sp>
         <p:nvSpPr>
-          <p:cNvPr id="46" name="S04_045"/>
+          <p:cNvPr id="13" name="S04_012"/>
           <p:cNvSpPr/>
           <p:nvPr/>
         </p:nvSpPr>
@@ -13052,14 +12171,14 @@
       </p:sp>
       <p:sp>
         <p:nvSpPr>
-          <p:cNvPr id="47" name="S04_046"/>
+          <p:cNvPr id="14" name="S04_013"/>
           <p:cNvSpPr/>
           <p:nvPr/>
         </p:nvSpPr>
         <p:spPr>
           <a:xfrm>
             <a:off x="0" y="6807200"/>
-            <a:ext cx="4741333" cy="50800"/>
+            <a:ext cx="4376615" cy="50800"/>
           </a:xfrm>
           <a:prstGeom prst="rect">
             <a:avLst/>
@@ -13098,7 +12217,7 @@
   <p:clrMapOvr>
     <a:masterClrMapping/>
   </p:clrMapOvr>
-  <p:transition advClick="1" advTm="25000"/>
+  <p:transition advClick="1" advTm="30000"/>
   <p:timing>
     <p:tnLst>
       <p:par>
@@ -13112,7 +12231,7 @@
                   </p:stCondLst>
                 </p:cTn>
                 <p:tgtEl>
-                  <p:spTgt spid="43"/>
+                  <p:spTgt spid="10"/>
                 </p:tgtEl>
               </p:cMediaNode>
             </p:video>
@@ -16324,7 +15443,7 @@
         <p:spPr>
           <a:xfrm>
             <a:off x="0" y="6807200"/>
-            <a:ext cx="6231466" cy="50800"/>
+            <a:ext cx="5158153" cy="50800"/>
           </a:xfrm>
           <a:prstGeom prst="rect">
             <a:avLst/>
@@ -16363,7 +15482,7 @@
   <p:clrMapOvr>
     <a:masterClrMapping/>
   </p:clrMapOvr>
-  <p:transition advClick="1" advTm="22000"/>
+  <p:transition advClick="1" advTm="10000"/>
   <p:timing>
     <p:tnLst>
       <p:par>
@@ -16629,7 +15748,7 @@
                 </a:solidFill>
                 <a:latin typeface="DejaVu Sans"/>
               </a:rPr>
-              <a:t>A05 / Measured restoration ablation</a:t>
+              <a:t>A05 / Benchmark tasks and measured ablation</a:t>
             </a:r>
           </a:p>
         </p:txBody>
@@ -17742,7 +16861,7 @@
         <p:spPr>
           <a:xfrm>
             <a:off x="0" y="6807200"/>
-            <a:ext cx="8128000" cy="50800"/>
+            <a:ext cx="7502769" cy="50800"/>
           </a:xfrm>
           <a:prstGeom prst="rect">
             <a:avLst/>
@@ -17781,7 +16900,7 @@
   <p:clrMapOvr>
     <a:masterClrMapping/>
   </p:clrMapOvr>
-  <p:transition advClick="1" advTm="28000"/>
+  <p:transition advClick="1" advTm="30000"/>
   <p:timing>
     <p:tnLst>
       <p:par>
@@ -18577,7 +17696,7 @@
         <p:spPr>
           <a:xfrm>
             <a:off x="0" y="6807200"/>
-            <a:ext cx="9211733" cy="50800"/>
+            <a:ext cx="8753230" cy="50800"/>
           </a:xfrm>
           <a:prstGeom prst="rect">
             <a:avLst/>
@@ -20048,7 +19167,7 @@
         <p:spPr>
           <a:xfrm>
             <a:off x="0" y="6807200"/>
-            <a:ext cx="10295466" cy="50800"/>
+            <a:ext cx="10003692" cy="50800"/>
           </a:xfrm>
           <a:prstGeom prst="rect">
             <a:avLst/>
@@ -21519,7 +20638,7 @@
         <p:spPr>
           <a:xfrm>
             <a:off x="0" y="6807200"/>
-            <a:ext cx="11650133" cy="50800"/>
+            <a:ext cx="11566769" cy="50800"/>
           </a:xfrm>
           <a:prstGeom prst="rect">
             <a:avLst/>

</xml_diff>